<commit_message>
feat: open the front slides with a 기도 준비 slide
Adds a new first slide to public/front-slides.pptx: black background,
"지금은 기도로 예배를 준비하는 시간입니다." centred at the top and two
bulleted 기도제목 lines. It hides the layout's logo (showMasterSp="0"),
and the in-app renderer now honours that flag too.

The bundled front deck is now 5 slides; the default count, the admin
label, README and the tests that count its slides are updated.

Co-Authored-By: Claude Opus 5.5 <noreply@anthropic.com>
Claude-Session: https://claude.ai/code/session_01Y2gSMfkFZPq53Q9fKQGJQo
</commit_message>
<xml_diff>
--- a/public/front-slides.pptx
+++ b/public/front-slides.pptx
@@ -8,6 +8,7 @@
     <p:notesMasterId r:id="rId6"/>
   </p:notesMasterIdLst>
   <p:sldIdLst>
+    <p:sldId id="900005" r:id="rId70"/>
     <p:sldId id="900001" r:id="rId2"/>
     <p:sldId id="900002" r:id="rId3"/>
     <p:sldId id="900003" r:id="rId4"/>
@@ -1726,7 +1727,7 @@
 </p:notesMaster>
 </file>
 
-<file path=ppt/notesSlides/notesSlide1.xml><?xml version="1.0" encoding="utf-8"?>
+<file path=ppt/notesSlides/notesSlide2.xml><?xml version="1.0" encoding="utf-8"?>
 <p:notes xmlns:a="http://schemas.openxmlformats.org/drawingml/2006/main" xmlns:r="http://schemas.openxmlformats.org/officeDocument/2006/relationships" xmlns:p="http://schemas.openxmlformats.org/presentationml/2006/main" showMasterSp="0" showMasterPhAnim="0">
   <p:cSld>
     <p:spTree>
@@ -1902,7 +1903,7 @@
 </p:notes>
 </file>
 
-<file path=ppt/notesSlides/notesSlide2.xml><?xml version="1.0" encoding="utf-8"?>
+<file path=ppt/notesSlides/notesSlide3.xml><?xml version="1.0" encoding="utf-8"?>
 <p:notes xmlns:a="http://schemas.openxmlformats.org/drawingml/2006/main" xmlns:r="http://schemas.openxmlformats.org/officeDocument/2006/relationships" xmlns:p="http://schemas.openxmlformats.org/presentationml/2006/main" showMasterSp="0" showMasterPhAnim="0">
   <p:cSld>
     <p:spTree>
@@ -2024,7 +2025,7 @@
 </p:notes>
 </file>
 
-<file path=ppt/notesSlides/notesSlide3.xml><?xml version="1.0" encoding="utf-8"?>
+<file path=ppt/notesSlides/notesSlide4.xml><?xml version="1.0" encoding="utf-8"?>
 <p:notes xmlns:a="http://schemas.openxmlformats.org/drawingml/2006/main" xmlns:r="http://schemas.openxmlformats.org/officeDocument/2006/relationships" xmlns:p="http://schemas.openxmlformats.org/presentationml/2006/main" showMasterSp="0" showMasterPhAnim="0">
   <p:cSld>
     <p:spTree>
@@ -2146,7 +2147,7 @@
 </p:notes>
 </file>
 
-<file path=ppt/notesSlides/notesSlide4.xml><?xml version="1.0" encoding="utf-8"?>
+<file path=ppt/notesSlides/notesSlide5.xml><?xml version="1.0" encoding="utf-8"?>
 <p:notes xmlns:a="http://schemas.openxmlformats.org/drawingml/2006/main" xmlns:r="http://schemas.openxmlformats.org/officeDocument/2006/relationships" xmlns:p="http://schemas.openxmlformats.org/presentationml/2006/main" showMasterSp="0" showMasterPhAnim="0">
   <p:cSld>
     <p:spTree>
@@ -11173,6 +11174,205 @@
 </file>
 
 <file path=ppt/slides/slide1.xml><?xml version="1.0" encoding="utf-8"?>
+<p:sld xmlns:a="http://schemas.openxmlformats.org/drawingml/2006/main" xmlns:r="http://schemas.openxmlformats.org/officeDocument/2006/relationships" xmlns:p="http://schemas.openxmlformats.org/presentationml/2006/main" showMasterSp="0">
+  <p:cSld>
+    <p:bg>
+      <p:bgPr>
+        <a:solidFill>
+          <a:srgbClr val="000000"/>
+        </a:solidFill>
+        <a:effectLst/>
+      </p:bgPr>
+    </p:bg>
+    <p:spTree>
+      <p:nvGrpSpPr>
+        <p:cNvPr id="1" name="Shape 1"/>
+        <p:cNvGrpSpPr/>
+        <p:nvPr/>
+      </p:nvGrpSpPr>
+      <p:grpSpPr>
+        <a:xfrm>
+          <a:off x="0" y="0"/>
+          <a:ext cx="0" cy="0"/>
+          <a:chOff x="0" y="0"/>
+          <a:chExt cx="0" cy="0"/>
+        </a:xfrm>
+      </p:grpSpPr>
+      <p:sp>
+        <p:nvSpPr>
+          <p:cNvPr id="2" name="기도 준비 제목"/>
+          <p:cNvSpPr txBox="1"/>
+          <p:nvPr/>
+        </p:nvSpPr>
+        <p:spPr>
+          <a:xfrm>
+            <a:off x="457200" y="457200"/>
+            <a:ext cx="8229600" cy="1143000"/>
+          </a:xfrm>
+          <a:prstGeom prst="rect">
+            <a:avLst/>
+          </a:prstGeom>
+          <a:noFill/>
+          <a:ln>
+            <a:noFill/>
+          </a:ln>
+        </p:spPr>
+        <p:txBody>
+          <a:bodyPr spcFirstLastPara="1" wrap="square" lIns="91425" tIns="45700" rIns="91425" bIns="45700" anchor="t" anchorCtr="0">
+            <a:noAutofit/>
+          </a:bodyPr>
+          <a:lstStyle/>
+          <a:p>
+            <a:pPr marL="0" lvl="0" indent="0" algn="ctr" rtl="0">
+              <a:lnSpc>
+                <a:spcPct val="100000"/>
+              </a:lnSpc>
+              <a:spcBef>
+                <a:spcPts val="0"/>
+              </a:spcBef>
+              <a:spcAft>
+                <a:spcPts val="0"/>
+              </a:spcAft>
+              <a:buNone/>
+            </a:pPr>
+            <a:r>
+              <a:rPr lang="ko-KR" sz="3000" b="0" i="0" u="none" strike="noStrike" cap="none">
+                <a:solidFill>
+                  <a:srgbClr val="FFFFFF"/>
+                </a:solidFill>
+                <a:latin typeface="Arial"/>
+                <a:ea typeface="Arial"/>
+                <a:cs typeface="Arial"/>
+                <a:sym typeface="Arial"/>
+              </a:rPr>
+              <a:t>지금은 기도로 예배를 준비하는</a:t>
+            </a:r>
+          </a:p>
+          <a:p>
+            <a:pPr marL="0" lvl="0" indent="0" algn="ctr" rtl="0">
+              <a:lnSpc>
+                <a:spcPct val="100000"/>
+              </a:lnSpc>
+              <a:spcBef>
+                <a:spcPts val="0"/>
+              </a:spcBef>
+              <a:spcAft>
+                <a:spcPts val="0"/>
+              </a:spcAft>
+              <a:buNone/>
+            </a:pPr>
+            <a:r>
+              <a:rPr lang="ko-KR" sz="3000" b="0" i="0" u="none" strike="noStrike" cap="none">
+                <a:solidFill>
+                  <a:srgbClr val="FFFFFF"/>
+                </a:solidFill>
+                <a:latin typeface="Arial"/>
+                <a:ea typeface="Arial"/>
+                <a:cs typeface="Arial"/>
+                <a:sym typeface="Arial"/>
+              </a:rPr>
+              <a:t>시간입니다.</a:t>
+            </a:r>
+          </a:p>
+        </p:txBody>
+      </p:sp>
+      <p:sp>
+        <p:nvSpPr>
+          <p:cNvPr id="3" name="기도제목"/>
+          <p:cNvSpPr txBox="1"/>
+          <p:nvPr/>
+        </p:nvSpPr>
+        <p:spPr>
+          <a:xfrm>
+            <a:off x="685800" y="1828800"/>
+            <a:ext cx="7772400" cy="4114800"/>
+          </a:xfrm>
+          <a:prstGeom prst="rect">
+            <a:avLst/>
+          </a:prstGeom>
+          <a:noFill/>
+          <a:ln>
+            <a:noFill/>
+          </a:ln>
+        </p:spPr>
+        <p:txBody>
+          <a:bodyPr spcFirstLastPara="1" wrap="square" lIns="91425" tIns="45700" rIns="91425" bIns="45700" anchor="t" anchorCtr="0">
+            <a:noAutofit/>
+          </a:bodyPr>
+          <a:lstStyle/>
+          <a:p>
+            <a:pPr marL="457200" lvl="0" indent="-381000" algn="l" rtl="0">
+              <a:lnSpc>
+                <a:spcPct val="100000"/>
+              </a:lnSpc>
+              <a:spcBef>
+                <a:spcPts val="0"/>
+              </a:spcBef>
+              <a:spcAft>
+                <a:spcPts val="4800"/>
+              </a:spcAft>
+              <a:buClr>
+                <a:srgbClr val="FFFFFF"/>
+              </a:buClr>
+              <a:buSzPts val="2000"/>
+              <a:buFont typeface="Arial"/>
+              <a:buChar char="●"/>
+            </a:pPr>
+            <a:r>
+              <a:rPr lang="ko-KR" sz="2000" b="0" i="0" u="none" strike="noStrike" cap="none">
+                <a:solidFill>
+                  <a:srgbClr val="FFFFFF"/>
+                </a:solidFill>
+                <a:latin typeface="Arial"/>
+                <a:ea typeface="Arial"/>
+                <a:cs typeface="Arial"/>
+                <a:sym typeface="Arial"/>
+              </a:rPr>
+              <a:t>기도제목 1</a:t>
+            </a:r>
+          </a:p>
+          <a:p>
+            <a:pPr marL="457200" lvl="0" indent="-381000" algn="l" rtl="0">
+              <a:lnSpc>
+                <a:spcPct val="100000"/>
+              </a:lnSpc>
+              <a:spcBef>
+                <a:spcPts val="0"/>
+              </a:spcBef>
+              <a:spcAft>
+                <a:spcPts val="4800"/>
+              </a:spcAft>
+              <a:buClr>
+                <a:srgbClr val="FFFFFF"/>
+              </a:buClr>
+              <a:buSzPts val="2000"/>
+              <a:buFont typeface="Arial"/>
+              <a:buChar char="●"/>
+            </a:pPr>
+            <a:r>
+              <a:rPr lang="ko-KR" sz="2000" b="0" i="0" u="none" strike="noStrike" cap="none">
+                <a:solidFill>
+                  <a:srgbClr val="FFFFFF"/>
+                </a:solidFill>
+                <a:latin typeface="Arial"/>
+                <a:ea typeface="Arial"/>
+                <a:cs typeface="Arial"/>
+                <a:sym typeface="Arial"/>
+              </a:rPr>
+              <a:t>기도제목 2</a:t>
+            </a:r>
+          </a:p>
+        </p:txBody>
+      </p:sp>
+    </p:spTree>
+  </p:cSld>
+  <p:clrMapOvr>
+    <a:masterClrMapping/>
+  </p:clrMapOvr>
+</p:sld>
+</file>
+
+<file path=ppt/slides/slide2.xml><?xml version="1.0" encoding="utf-8"?>
 <p:sld xmlns:a="http://schemas.openxmlformats.org/drawingml/2006/main" xmlns:r="http://schemas.openxmlformats.org/officeDocument/2006/relationships" xmlns:p="http://schemas.openxmlformats.org/presentationml/2006/main">
   <p:cSld>
     <p:spTree>
@@ -11402,7 +11602,7 @@
 </p:sld>
 </file>
 
-<file path=ppt/slides/slide2.xml><?xml version="1.0" encoding="utf-8"?>
+<file path=ppt/slides/slide3.xml><?xml version="1.0" encoding="utf-8"?>
 <p:sld xmlns:a="http://schemas.openxmlformats.org/drawingml/2006/main" xmlns:r="http://schemas.openxmlformats.org/officeDocument/2006/relationships" xmlns:p="http://schemas.openxmlformats.org/presentationml/2006/main">
   <p:cSld>
     <p:bg>
@@ -11653,7 +11853,7 @@
 </p:sld>
 </file>
 
-<file path=ppt/slides/slide3.xml><?xml version="1.0" encoding="utf-8"?>
+<file path=ppt/slides/slide4.xml><?xml version="1.0" encoding="utf-8"?>
 <p:sld xmlns:a="http://schemas.openxmlformats.org/drawingml/2006/main" xmlns:r="http://schemas.openxmlformats.org/officeDocument/2006/relationships" xmlns:p="http://schemas.openxmlformats.org/presentationml/2006/main">
   <p:cSld>
     <p:bg>
@@ -13566,7 +13766,7 @@
 </p:sld>
 </file>
 
-<file path=ppt/slides/slide4.xml><?xml version="1.0" encoding="utf-8"?>
+<file path=ppt/slides/slide5.xml><?xml version="1.0" encoding="utf-8"?>
 <p:sld xmlns:a="http://schemas.openxmlformats.org/drawingml/2006/main" xmlns:r="http://schemas.openxmlformats.org/officeDocument/2006/relationships" xmlns:p="http://schemas.openxmlformats.org/presentationml/2006/main">
   <p:cSld>
     <p:bg>

</xml_diff>